<commit_message>
Atualiza programa no GitHub
</commit_message>
<xml_diff>
--- a/Apresentaçao_Pap.pptx
+++ b/Apresentaçao_Pap.pptx
@@ -8,10 +8,11 @@
     <p:sldId id="256" r:id="rId2"/>
     <p:sldId id="257" r:id="rId3"/>
     <p:sldId id="262" r:id="rId4"/>
-    <p:sldId id="258" r:id="rId5"/>
-    <p:sldId id="259" r:id="rId6"/>
-    <p:sldId id="260" r:id="rId7"/>
-    <p:sldId id="261" r:id="rId8"/>
+    <p:sldId id="263" r:id="rId5"/>
+    <p:sldId id="258" r:id="rId6"/>
+    <p:sldId id="259" r:id="rId7"/>
+    <p:sldId id="260" r:id="rId8"/>
+    <p:sldId id="261" r:id="rId9"/>
   </p:sldIdLst>
   <p:sldSz cx="12192000" cy="6858000"/>
   <p:notesSz cx="6858000" cy="9144000"/>
@@ -10874,6 +10875,733 @@
 <file path=ppt/slides/slide4.xml><?xml version="1.0" encoding="utf-8"?>
 <p:sld xmlns:a="http://schemas.openxmlformats.org/drawingml/2006/main" xmlns:r="http://schemas.openxmlformats.org/officeDocument/2006/relationships" xmlns:p="http://schemas.openxmlformats.org/presentationml/2006/main">
   <p:cSld>
+    <p:spTree>
+      <p:nvGrpSpPr>
+        <p:cNvPr id="1" name=""/>
+        <p:cNvGrpSpPr/>
+        <p:nvPr/>
+      </p:nvGrpSpPr>
+      <p:grpSpPr>
+        <a:xfrm>
+          <a:off x="0" y="0"/>
+          <a:ext cx="0" cy="0"/>
+          <a:chOff x="0" y="0"/>
+          <a:chExt cx="0" cy="0"/>
+        </a:xfrm>
+      </p:grpSpPr>
+      <p:sp>
+        <p:nvSpPr>
+          <p:cNvPr id="2" name="Título 1">
+            <a:extLst>
+              <a:ext uri="{FF2B5EF4-FFF2-40B4-BE49-F238E27FC236}">
+                <a16:creationId xmlns:a16="http://schemas.microsoft.com/office/drawing/2014/main" id="{030AB7C2-6B08-B9FC-7760-ECC4A10AC29C}"/>
+              </a:ext>
+            </a:extLst>
+          </p:cNvPr>
+          <p:cNvSpPr>
+            <a:spLocks noGrp="1"/>
+          </p:cNvSpPr>
+          <p:nvPr>
+            <p:ph type="title"/>
+          </p:nvPr>
+        </p:nvSpPr>
+        <p:spPr/>
+        <p:txBody>
+          <a:bodyPr/>
+          <a:lstStyle/>
+          <a:p>
+            <a:r>
+              <a:rPr lang="pt-PT" dirty="0"/>
+              <a:t>Esquema de navegação</a:t>
+            </a:r>
+          </a:p>
+        </p:txBody>
+      </p:sp>
+      <p:sp>
+        <p:nvSpPr>
+          <p:cNvPr id="4" name="Retângulo 3">
+            <a:extLst>
+              <a:ext uri="{FF2B5EF4-FFF2-40B4-BE49-F238E27FC236}">
+                <a16:creationId xmlns:a16="http://schemas.microsoft.com/office/drawing/2014/main" id="{D443B318-3966-C0A6-C6E6-BF3A674E53D7}"/>
+              </a:ext>
+            </a:extLst>
+          </p:cNvPr>
+          <p:cNvSpPr/>
+          <p:nvPr/>
+        </p:nvSpPr>
+        <p:spPr>
+          <a:xfrm>
+            <a:off x="5135880" y="1690688"/>
+            <a:ext cx="1920240" cy="612648"/>
+          </a:xfrm>
+          <a:prstGeom prst="rect">
+            <a:avLst/>
+          </a:prstGeom>
+          <a:solidFill>
+            <a:schemeClr val="lt1"/>
+          </a:solidFill>
+          <a:ln>
+            <a:solidFill>
+              <a:srgbClr val="0045AA"/>
+            </a:solidFill>
+          </a:ln>
+        </p:spPr>
+        <p:style>
+          <a:lnRef idx="2">
+            <a:schemeClr val="accent6"/>
+          </a:lnRef>
+          <a:fillRef idx="1">
+            <a:schemeClr val="lt1"/>
+          </a:fillRef>
+          <a:effectRef idx="0">
+            <a:schemeClr val="accent6"/>
+          </a:effectRef>
+          <a:fontRef idx="minor">
+            <a:schemeClr val="dk1"/>
+          </a:fontRef>
+        </p:style>
+        <p:txBody>
+          <a:bodyPr rtlCol="0" anchor="ctr"/>
+          <a:lstStyle/>
+          <a:p>
+            <a:pPr algn="ctr"/>
+            <a:r>
+              <a:rPr lang="pt-PT" dirty="0">
+                <a:ln>
+                  <a:solidFill>
+                    <a:schemeClr val="tx1"/>
+                  </a:solidFill>
+                </a:ln>
+              </a:rPr>
+              <a:t>Menu Inicial </a:t>
+            </a:r>
+          </a:p>
+        </p:txBody>
+      </p:sp>
+      <p:cxnSp>
+        <p:nvCxnSpPr>
+          <p:cNvPr id="8" name="Conexão Reta 7">
+            <a:extLst>
+              <a:ext uri="{FF2B5EF4-FFF2-40B4-BE49-F238E27FC236}">
+                <a16:creationId xmlns:a16="http://schemas.microsoft.com/office/drawing/2014/main" id="{2A471DC0-85E6-92A3-76D9-39781CBFD138}"/>
+              </a:ext>
+            </a:extLst>
+          </p:cNvPr>
+          <p:cNvCxnSpPr>
+            <a:cxnSpLocks/>
+            <a:stCxn id="4" idx="2"/>
+          </p:cNvCxnSpPr>
+          <p:nvPr/>
+        </p:nvCxnSpPr>
+        <p:spPr>
+          <a:xfrm>
+            <a:off x="6096000" y="2303336"/>
+            <a:ext cx="0" cy="860488"/>
+          </a:xfrm>
+          <a:prstGeom prst="line">
+            <a:avLst/>
+          </a:prstGeom>
+          <a:ln>
+            <a:solidFill>
+              <a:srgbClr val="0045AA"/>
+            </a:solidFill>
+          </a:ln>
+        </p:spPr>
+        <p:style>
+          <a:lnRef idx="2">
+            <a:schemeClr val="accent1"/>
+          </a:lnRef>
+          <a:fillRef idx="0">
+            <a:schemeClr val="accent1"/>
+          </a:fillRef>
+          <a:effectRef idx="1">
+            <a:schemeClr val="accent1"/>
+          </a:effectRef>
+          <a:fontRef idx="minor">
+            <a:schemeClr val="tx1"/>
+          </a:fontRef>
+        </p:style>
+      </p:cxnSp>
+      <p:cxnSp>
+        <p:nvCxnSpPr>
+          <p:cNvPr id="14" name="Conexão Reta 13">
+            <a:extLst>
+              <a:ext uri="{FF2B5EF4-FFF2-40B4-BE49-F238E27FC236}">
+                <a16:creationId xmlns:a16="http://schemas.microsoft.com/office/drawing/2014/main" id="{E6291F50-D41D-0066-3950-5195690AB741}"/>
+              </a:ext>
+            </a:extLst>
+          </p:cNvPr>
+          <p:cNvCxnSpPr>
+            <a:cxnSpLocks/>
+          </p:cNvCxnSpPr>
+          <p:nvPr/>
+        </p:nvCxnSpPr>
+        <p:spPr>
+          <a:xfrm flipH="1">
+            <a:off x="1709928" y="3154680"/>
+            <a:ext cx="8729472" cy="0"/>
+          </a:xfrm>
+          <a:prstGeom prst="line">
+            <a:avLst/>
+          </a:prstGeom>
+          <a:ln>
+            <a:solidFill>
+              <a:srgbClr val="0045AA"/>
+            </a:solidFill>
+          </a:ln>
+        </p:spPr>
+        <p:style>
+          <a:lnRef idx="2">
+            <a:schemeClr val="accent1"/>
+          </a:lnRef>
+          <a:fillRef idx="0">
+            <a:schemeClr val="accent1"/>
+          </a:fillRef>
+          <a:effectRef idx="1">
+            <a:schemeClr val="accent1"/>
+          </a:effectRef>
+          <a:fontRef idx="minor">
+            <a:schemeClr val="tx1"/>
+          </a:fontRef>
+        </p:style>
+      </p:cxnSp>
+      <p:sp>
+        <p:nvSpPr>
+          <p:cNvPr id="17" name="Retângulo 16">
+            <a:extLst>
+              <a:ext uri="{FF2B5EF4-FFF2-40B4-BE49-F238E27FC236}">
+                <a16:creationId xmlns:a16="http://schemas.microsoft.com/office/drawing/2014/main" id="{4D8C4B27-4963-F160-54CF-F5540900F2D3}"/>
+              </a:ext>
+            </a:extLst>
+          </p:cNvPr>
+          <p:cNvSpPr/>
+          <p:nvPr/>
+        </p:nvSpPr>
+        <p:spPr>
+          <a:xfrm>
+            <a:off x="749808" y="3781616"/>
+            <a:ext cx="1920240" cy="612648"/>
+          </a:xfrm>
+          <a:prstGeom prst="rect">
+            <a:avLst/>
+          </a:prstGeom>
+          <a:solidFill>
+            <a:schemeClr val="lt1"/>
+          </a:solidFill>
+          <a:ln>
+            <a:solidFill>
+              <a:srgbClr val="0045AA"/>
+            </a:solidFill>
+          </a:ln>
+        </p:spPr>
+        <p:style>
+          <a:lnRef idx="2">
+            <a:schemeClr val="accent6"/>
+          </a:lnRef>
+          <a:fillRef idx="1">
+            <a:schemeClr val="lt1"/>
+          </a:fillRef>
+          <a:effectRef idx="0">
+            <a:schemeClr val="accent6"/>
+          </a:effectRef>
+          <a:fontRef idx="minor">
+            <a:schemeClr val="dk1"/>
+          </a:fontRef>
+        </p:style>
+        <p:txBody>
+          <a:bodyPr rtlCol="0" anchor="ctr"/>
+          <a:lstStyle/>
+          <a:p>
+            <a:pPr algn="ctr"/>
+            <a:r>
+              <a:rPr lang="pt-PT" dirty="0">
+                <a:ln>
+                  <a:solidFill>
+                    <a:schemeClr val="tx1"/>
+                  </a:solidFill>
+                </a:ln>
+              </a:rPr>
+              <a:t>Visão geral</a:t>
+            </a:r>
+          </a:p>
+        </p:txBody>
+      </p:sp>
+      <p:sp>
+        <p:nvSpPr>
+          <p:cNvPr id="18" name="Retângulo 17">
+            <a:extLst>
+              <a:ext uri="{FF2B5EF4-FFF2-40B4-BE49-F238E27FC236}">
+                <a16:creationId xmlns:a16="http://schemas.microsoft.com/office/drawing/2014/main" id="{513C1DF7-1AA7-1A4A-6710-F16FAE3618DE}"/>
+              </a:ext>
+            </a:extLst>
+          </p:cNvPr>
+          <p:cNvSpPr/>
+          <p:nvPr/>
+        </p:nvSpPr>
+        <p:spPr>
+          <a:xfrm>
+            <a:off x="7296912" y="3763328"/>
+            <a:ext cx="1920240" cy="612648"/>
+          </a:xfrm>
+          <a:prstGeom prst="rect">
+            <a:avLst/>
+          </a:prstGeom>
+          <a:solidFill>
+            <a:schemeClr val="lt1"/>
+          </a:solidFill>
+          <a:ln>
+            <a:solidFill>
+              <a:srgbClr val="0045AA"/>
+            </a:solidFill>
+          </a:ln>
+        </p:spPr>
+        <p:style>
+          <a:lnRef idx="2">
+            <a:schemeClr val="accent6"/>
+          </a:lnRef>
+          <a:fillRef idx="1">
+            <a:schemeClr val="lt1"/>
+          </a:fillRef>
+          <a:effectRef idx="0">
+            <a:schemeClr val="accent6"/>
+          </a:effectRef>
+          <a:fontRef idx="minor">
+            <a:schemeClr val="dk1"/>
+          </a:fontRef>
+        </p:style>
+        <p:txBody>
+          <a:bodyPr rtlCol="0" anchor="ctr"/>
+          <a:lstStyle/>
+          <a:p>
+            <a:pPr algn="ctr"/>
+            <a:r>
+              <a:rPr lang="pt-PT" dirty="0">
+                <a:ln>
+                  <a:solidFill>
+                    <a:schemeClr val="tx1"/>
+                  </a:solidFill>
+                </a:ln>
+              </a:rPr>
+              <a:t>Objetivos</a:t>
+            </a:r>
+          </a:p>
+        </p:txBody>
+      </p:sp>
+      <p:sp>
+        <p:nvSpPr>
+          <p:cNvPr id="19" name="Retângulo 18">
+            <a:extLst>
+              <a:ext uri="{FF2B5EF4-FFF2-40B4-BE49-F238E27FC236}">
+                <a16:creationId xmlns:a16="http://schemas.microsoft.com/office/drawing/2014/main" id="{4B7D3673-1B64-C9F6-A7EB-98AB71A061A0}"/>
+              </a:ext>
+            </a:extLst>
+          </p:cNvPr>
+          <p:cNvSpPr/>
+          <p:nvPr/>
+        </p:nvSpPr>
+        <p:spPr>
+          <a:xfrm>
+            <a:off x="5114544" y="3776472"/>
+            <a:ext cx="1920240" cy="612648"/>
+          </a:xfrm>
+          <a:prstGeom prst="rect">
+            <a:avLst/>
+          </a:prstGeom>
+          <a:solidFill>
+            <a:schemeClr val="lt1"/>
+          </a:solidFill>
+          <a:ln>
+            <a:solidFill>
+              <a:srgbClr val="0045AA"/>
+            </a:solidFill>
+          </a:ln>
+        </p:spPr>
+        <p:style>
+          <a:lnRef idx="2">
+            <a:schemeClr val="accent6"/>
+          </a:lnRef>
+          <a:fillRef idx="1">
+            <a:schemeClr val="lt1"/>
+          </a:fillRef>
+          <a:effectRef idx="0">
+            <a:schemeClr val="accent6"/>
+          </a:effectRef>
+          <a:fontRef idx="minor">
+            <a:schemeClr val="dk1"/>
+          </a:fontRef>
+        </p:style>
+        <p:txBody>
+          <a:bodyPr rtlCol="0" anchor="ctr"/>
+          <a:lstStyle/>
+          <a:p>
+            <a:pPr algn="ctr"/>
+            <a:r>
+              <a:rPr lang="pt-PT" dirty="0">
+                <a:ln>
+                  <a:solidFill>
+                    <a:schemeClr val="tx1"/>
+                  </a:solidFill>
+                </a:ln>
+              </a:rPr>
+              <a:t>Loja</a:t>
+            </a:r>
+          </a:p>
+        </p:txBody>
+      </p:sp>
+      <p:sp>
+        <p:nvSpPr>
+          <p:cNvPr id="20" name="Retângulo 19">
+            <a:extLst>
+              <a:ext uri="{FF2B5EF4-FFF2-40B4-BE49-F238E27FC236}">
+                <a16:creationId xmlns:a16="http://schemas.microsoft.com/office/drawing/2014/main" id="{9D178CE4-8312-BEEE-A96F-58FAF237697A}"/>
+              </a:ext>
+            </a:extLst>
+          </p:cNvPr>
+          <p:cNvSpPr/>
+          <p:nvPr/>
+        </p:nvSpPr>
+        <p:spPr>
+          <a:xfrm>
+            <a:off x="2932176" y="3763328"/>
+            <a:ext cx="1920240" cy="612648"/>
+          </a:xfrm>
+          <a:prstGeom prst="rect">
+            <a:avLst/>
+          </a:prstGeom>
+          <a:solidFill>
+            <a:schemeClr val="lt1"/>
+          </a:solidFill>
+          <a:ln>
+            <a:solidFill>
+              <a:srgbClr val="0045AA"/>
+            </a:solidFill>
+          </a:ln>
+        </p:spPr>
+        <p:style>
+          <a:lnRef idx="2">
+            <a:schemeClr val="accent6"/>
+          </a:lnRef>
+          <a:fillRef idx="1">
+            <a:schemeClr val="lt1"/>
+          </a:fillRef>
+          <a:effectRef idx="0">
+            <a:schemeClr val="accent6"/>
+          </a:effectRef>
+          <a:fontRef idx="minor">
+            <a:schemeClr val="dk1"/>
+          </a:fontRef>
+        </p:style>
+        <p:txBody>
+          <a:bodyPr rtlCol="0" anchor="ctr"/>
+          <a:lstStyle/>
+          <a:p>
+            <a:pPr algn="ctr"/>
+            <a:r>
+              <a:rPr lang="pt-PT" dirty="0">
+                <a:ln>
+                  <a:solidFill>
+                    <a:schemeClr val="tx1"/>
+                  </a:solidFill>
+                </a:ln>
+              </a:rPr>
+              <a:t>Banco</a:t>
+            </a:r>
+          </a:p>
+        </p:txBody>
+      </p:sp>
+      <p:sp>
+        <p:nvSpPr>
+          <p:cNvPr id="21" name="Retângulo 20">
+            <a:extLst>
+              <a:ext uri="{FF2B5EF4-FFF2-40B4-BE49-F238E27FC236}">
+                <a16:creationId xmlns:a16="http://schemas.microsoft.com/office/drawing/2014/main" id="{4AD41816-2A14-891B-DE9F-A41C4FAB5B7E}"/>
+              </a:ext>
+            </a:extLst>
+          </p:cNvPr>
+          <p:cNvSpPr/>
+          <p:nvPr/>
+        </p:nvSpPr>
+        <p:spPr>
+          <a:xfrm>
+            <a:off x="9479280" y="3759328"/>
+            <a:ext cx="1920240" cy="612648"/>
+          </a:xfrm>
+          <a:prstGeom prst="rect">
+            <a:avLst/>
+          </a:prstGeom>
+          <a:solidFill>
+            <a:schemeClr val="lt1"/>
+          </a:solidFill>
+          <a:ln>
+            <a:solidFill>
+              <a:srgbClr val="0045AA"/>
+            </a:solidFill>
+          </a:ln>
+        </p:spPr>
+        <p:style>
+          <a:lnRef idx="2">
+            <a:schemeClr val="accent6"/>
+          </a:lnRef>
+          <a:fillRef idx="1">
+            <a:schemeClr val="lt1"/>
+          </a:fillRef>
+          <a:effectRef idx="0">
+            <a:schemeClr val="accent6"/>
+          </a:effectRef>
+          <a:fontRef idx="minor">
+            <a:schemeClr val="dk1"/>
+          </a:fontRef>
+        </p:style>
+        <p:txBody>
+          <a:bodyPr rtlCol="0" anchor="ctr"/>
+          <a:lstStyle/>
+          <a:p>
+            <a:pPr algn="ctr"/>
+            <a:r>
+              <a:rPr lang="pt-PT" dirty="0">
+                <a:ln>
+                  <a:solidFill>
+                    <a:schemeClr val="tx1"/>
+                  </a:solidFill>
+                </a:ln>
+              </a:rPr>
+              <a:t>Trofeus</a:t>
+            </a:r>
+          </a:p>
+        </p:txBody>
+      </p:sp>
+      <p:cxnSp>
+        <p:nvCxnSpPr>
+          <p:cNvPr id="23" name="Conexão Reta 22">
+            <a:extLst>
+              <a:ext uri="{FF2B5EF4-FFF2-40B4-BE49-F238E27FC236}">
+                <a16:creationId xmlns:a16="http://schemas.microsoft.com/office/drawing/2014/main" id="{D658B896-7949-2694-8A90-49A668129B68}"/>
+              </a:ext>
+            </a:extLst>
+          </p:cNvPr>
+          <p:cNvCxnSpPr>
+            <a:cxnSpLocks/>
+            <a:endCxn id="17" idx="0"/>
+          </p:cNvCxnSpPr>
+          <p:nvPr/>
+        </p:nvCxnSpPr>
+        <p:spPr>
+          <a:xfrm>
+            <a:off x="1709928" y="3154680"/>
+            <a:ext cx="0" cy="626936"/>
+          </a:xfrm>
+          <a:prstGeom prst="line">
+            <a:avLst/>
+          </a:prstGeom>
+          <a:ln>
+            <a:solidFill>
+              <a:srgbClr val="0045AA"/>
+            </a:solidFill>
+          </a:ln>
+        </p:spPr>
+        <p:style>
+          <a:lnRef idx="2">
+            <a:schemeClr val="accent1"/>
+          </a:lnRef>
+          <a:fillRef idx="0">
+            <a:schemeClr val="accent1"/>
+          </a:fillRef>
+          <a:effectRef idx="1">
+            <a:schemeClr val="accent1"/>
+          </a:effectRef>
+          <a:fontRef idx="minor">
+            <a:schemeClr val="tx1"/>
+          </a:fontRef>
+        </p:style>
+      </p:cxnSp>
+      <p:cxnSp>
+        <p:nvCxnSpPr>
+          <p:cNvPr id="26" name="Conexão Reta 25">
+            <a:extLst>
+              <a:ext uri="{FF2B5EF4-FFF2-40B4-BE49-F238E27FC236}">
+                <a16:creationId xmlns:a16="http://schemas.microsoft.com/office/drawing/2014/main" id="{696434F5-FB71-4E56-7B79-1AFF2FBDBD2C}"/>
+              </a:ext>
+            </a:extLst>
+          </p:cNvPr>
+          <p:cNvCxnSpPr>
+            <a:cxnSpLocks/>
+          </p:cNvCxnSpPr>
+          <p:nvPr/>
+        </p:nvCxnSpPr>
+        <p:spPr>
+          <a:xfrm>
+            <a:off x="3892296" y="3145536"/>
+            <a:ext cx="0" cy="626936"/>
+          </a:xfrm>
+          <a:prstGeom prst="line">
+            <a:avLst/>
+          </a:prstGeom>
+          <a:ln>
+            <a:solidFill>
+              <a:srgbClr val="0045AA"/>
+            </a:solidFill>
+          </a:ln>
+        </p:spPr>
+        <p:style>
+          <a:lnRef idx="2">
+            <a:schemeClr val="accent1"/>
+          </a:lnRef>
+          <a:fillRef idx="0">
+            <a:schemeClr val="accent1"/>
+          </a:fillRef>
+          <a:effectRef idx="1">
+            <a:schemeClr val="accent1"/>
+          </a:effectRef>
+          <a:fontRef idx="minor">
+            <a:schemeClr val="tx1"/>
+          </a:fontRef>
+        </p:style>
+      </p:cxnSp>
+      <p:cxnSp>
+        <p:nvCxnSpPr>
+          <p:cNvPr id="27" name="Conexão Reta 26">
+            <a:extLst>
+              <a:ext uri="{FF2B5EF4-FFF2-40B4-BE49-F238E27FC236}">
+                <a16:creationId xmlns:a16="http://schemas.microsoft.com/office/drawing/2014/main" id="{3AE6133D-218C-4440-DDCB-F50622FF3184}"/>
+              </a:ext>
+            </a:extLst>
+          </p:cNvPr>
+          <p:cNvCxnSpPr>
+            <a:cxnSpLocks/>
+          </p:cNvCxnSpPr>
+          <p:nvPr/>
+        </p:nvCxnSpPr>
+        <p:spPr>
+          <a:xfrm>
+            <a:off x="6096000" y="3132392"/>
+            <a:ext cx="0" cy="626936"/>
+          </a:xfrm>
+          <a:prstGeom prst="line">
+            <a:avLst/>
+          </a:prstGeom>
+          <a:ln>
+            <a:solidFill>
+              <a:srgbClr val="0045AA"/>
+            </a:solidFill>
+          </a:ln>
+        </p:spPr>
+        <p:style>
+          <a:lnRef idx="2">
+            <a:schemeClr val="accent1"/>
+          </a:lnRef>
+          <a:fillRef idx="0">
+            <a:schemeClr val="accent1"/>
+          </a:fillRef>
+          <a:effectRef idx="1">
+            <a:schemeClr val="accent1"/>
+          </a:effectRef>
+          <a:fontRef idx="minor">
+            <a:schemeClr val="tx1"/>
+          </a:fontRef>
+        </p:style>
+      </p:cxnSp>
+      <p:cxnSp>
+        <p:nvCxnSpPr>
+          <p:cNvPr id="28" name="Conexão Reta 27">
+            <a:extLst>
+              <a:ext uri="{FF2B5EF4-FFF2-40B4-BE49-F238E27FC236}">
+                <a16:creationId xmlns:a16="http://schemas.microsoft.com/office/drawing/2014/main" id="{714C9CA7-771A-F670-9FBE-E71658CA01AA}"/>
+              </a:ext>
+            </a:extLst>
+          </p:cNvPr>
+          <p:cNvCxnSpPr>
+            <a:cxnSpLocks/>
+          </p:cNvCxnSpPr>
+          <p:nvPr/>
+        </p:nvCxnSpPr>
+        <p:spPr>
+          <a:xfrm>
+            <a:off x="8235696" y="3154204"/>
+            <a:ext cx="0" cy="626936"/>
+          </a:xfrm>
+          <a:prstGeom prst="line">
+            <a:avLst/>
+          </a:prstGeom>
+          <a:ln>
+            <a:solidFill>
+              <a:srgbClr val="0045AA"/>
+            </a:solidFill>
+          </a:ln>
+        </p:spPr>
+        <p:style>
+          <a:lnRef idx="2">
+            <a:schemeClr val="accent1"/>
+          </a:lnRef>
+          <a:fillRef idx="0">
+            <a:schemeClr val="accent1"/>
+          </a:fillRef>
+          <a:effectRef idx="1">
+            <a:schemeClr val="accent1"/>
+          </a:effectRef>
+          <a:fontRef idx="minor">
+            <a:schemeClr val="tx1"/>
+          </a:fontRef>
+        </p:style>
+      </p:cxnSp>
+      <p:cxnSp>
+        <p:nvCxnSpPr>
+          <p:cNvPr id="30" name="Conexão Reta 29">
+            <a:extLst>
+              <a:ext uri="{FF2B5EF4-FFF2-40B4-BE49-F238E27FC236}">
+                <a16:creationId xmlns:a16="http://schemas.microsoft.com/office/drawing/2014/main" id="{85D52E50-8057-E94F-3D5E-FC64135DB1A8}"/>
+              </a:ext>
+            </a:extLst>
+          </p:cNvPr>
+          <p:cNvCxnSpPr>
+            <a:cxnSpLocks/>
+          </p:cNvCxnSpPr>
+          <p:nvPr/>
+        </p:nvCxnSpPr>
+        <p:spPr>
+          <a:xfrm>
+            <a:off x="10439400" y="3132392"/>
+            <a:ext cx="0" cy="626936"/>
+          </a:xfrm>
+          <a:prstGeom prst="line">
+            <a:avLst/>
+          </a:prstGeom>
+          <a:ln>
+            <a:solidFill>
+              <a:srgbClr val="0045AA"/>
+            </a:solidFill>
+          </a:ln>
+        </p:spPr>
+        <p:style>
+          <a:lnRef idx="2">
+            <a:schemeClr val="accent1"/>
+          </a:lnRef>
+          <a:fillRef idx="0">
+            <a:schemeClr val="accent1"/>
+          </a:fillRef>
+          <a:effectRef idx="1">
+            <a:schemeClr val="accent1"/>
+          </a:effectRef>
+          <a:fontRef idx="minor">
+            <a:schemeClr val="tx1"/>
+          </a:fontRef>
+        </p:style>
+      </p:cxnSp>
+    </p:spTree>
+    <p:extLst>
+      <p:ext uri="{BB962C8B-B14F-4D97-AF65-F5344CB8AC3E}">
+        <p14:creationId xmlns:p14="http://schemas.microsoft.com/office/powerpoint/2010/main" val="1114758912"/>
+      </p:ext>
+    </p:extLst>
+  </p:cSld>
+  <p:clrMapOvr>
+    <a:masterClrMapping/>
+  </p:clrMapOvr>
+</p:sld>
+</file>
+
+<file path=ppt/slides/slide5.xml><?xml version="1.0" encoding="utf-8"?>
+<p:sld xmlns:a="http://schemas.openxmlformats.org/drawingml/2006/main" xmlns:r="http://schemas.openxmlformats.org/officeDocument/2006/relationships" xmlns:p="http://schemas.openxmlformats.org/presentationml/2006/main">
+  <p:cSld>
     <p:bg>
       <p:bgPr>
         <a:solidFill>
@@ -11135,7 +11863,7 @@
 </p:sld>
 </file>
 
-<file path=ppt/slides/slide5.xml><?xml version="1.0" encoding="utf-8"?>
+<file path=ppt/slides/slide6.xml><?xml version="1.0" encoding="utf-8"?>
 <p:sld xmlns:a="http://schemas.openxmlformats.org/drawingml/2006/main" xmlns:r="http://schemas.openxmlformats.org/officeDocument/2006/relationships" xmlns:p="http://schemas.openxmlformats.org/presentationml/2006/main">
   <p:cSld>
     <p:bg>
@@ -11569,7 +12297,7 @@
 </p:sld>
 </file>
 
-<file path=ppt/slides/slide6.xml><?xml version="1.0" encoding="utf-8"?>
+<file path=ppt/slides/slide7.xml><?xml version="1.0" encoding="utf-8"?>
 <p:sld xmlns:a="http://schemas.openxmlformats.org/drawingml/2006/main" xmlns:r="http://schemas.openxmlformats.org/officeDocument/2006/relationships" xmlns:p="http://schemas.openxmlformats.org/presentationml/2006/main">
   <p:cSld>
     <p:bg>
@@ -12864,7 +13592,7 @@
 </p:sld>
 </file>
 
-<file path=ppt/slides/slide7.xml><?xml version="1.0" encoding="utf-8"?>
+<file path=ppt/slides/slide8.xml><?xml version="1.0" encoding="utf-8"?>
 <p:sld xmlns:a="http://schemas.openxmlformats.org/drawingml/2006/main" xmlns:r="http://schemas.openxmlformats.org/officeDocument/2006/relationships" xmlns:p="http://schemas.openxmlformats.org/presentationml/2006/main">
   <p:cSld>
     <p:bg>

</xml_diff>